<commit_message>
Adiciona similaridade semântica como métrica complementar ao ROUGE
ROUGE mede sobreposição de palavras e penaliza parafraseamento correto — os
resumos humanos do dataset são estilizados, não descritivos, então duas frases
com o mesmo significado raramente compartilham palavras. Adiciona similaridade
semântica (cosseno entre embeddings, reaproveitando o mesmo all-MiniLM-L6-v2 já
usado no RAG, sem depender de um segundo modelo tipo BERTScore) para medir
significado em vez de overlap léxico: 0,44 vs. ROUGE-L de 0,19, confirmando que
os resumos capturam o conteúdo mesmo com baixo overlap de palavras.

Atualiza slides e README com os números recalculados.
</commit_message>
<xml_diff>
--- a/slides/A3Data_Desafio_Tecnico.pptx
+++ b/slides/A3Data_Desafio_Tecnico.pptx
@@ -3788,7 +3788,7 @@
         <p:spPr>
           <a:xfrm>
             <a:off x="457200" y="1691640"/>
-            <a:ext cx="3596640" cy="2615738"/>
+            <a:ext cx="3596640" cy="2213317"/>
           </a:xfrm>
           <a:prstGeom prst="rect">
             <a:avLst/>
@@ -4028,7 +4028,7 @@
                 </a:solidFill>
                 <a:latin typeface="Segoe UI"/>
               </a:rPr>
-              <a:t>•  Sumarização — ROUGE-1/2/L (0,21 / 0,05 / 0,21): comparação objetiva contra resumo humano real já presente no dataset (referência gold), não uma amostra sintética.</a:t>
+              <a:t>•  Sumarização — ROUGE-1/2/L (0,19 / 0,11 / 0,19) mede sobreposição de palavras contra o resumo humano real (referência gold); similaridade semântica via embeddings (0,44) mede significado — as duas juntas mostram que o resumo é fiel mesmo quando ROUGE sozinho pareceria baixo.</a:t>
             </a:r>
           </a:p>
           <a:p>
@@ -8254,7 +8254,7 @@
                 </a:solidFill>
                 <a:latin typeface="Segoe UI"/>
               </a:rPr>
-              <a:t>•  Avaliação objetiva: ROUGE-L de 0,21 comparando resumos de review individual contra o resumo humano real já presente no dataset — indicador consistente, não é meta a maximizar isoladamente (resumos humanos são estilizados e variam muito entre si).</a:t>
+              <a:t>•  Avaliação objetiva: ROUGE-L de 0,19 comparando resumos de review individual contra o resumo humano real já presente no dataset — mas similaridade semântica (embeddings) de 0,44, bem mais alta, confirmando que o resumo captura o significado mesmo usando palavras diferentes do resumo humano (que é estilizado, não descritivo).</a:t>
             </a:r>
           </a:p>
           <a:p>

</xml_diff>